<commit_message>
Publish Sol-signed pre-kickoff reference baseline
</commit_message>
<xml_diff>
--- a/assets/submission/ShadowSpec-Hackathon-Deck.pptx
+++ b/assets/submission/ShadowSpec-Hackathon-Deck.pptx
@@ -2,18 +2,18 @@
 <file path=ppt/presentation.xml><?xml version="1.0" encoding="utf-8"?>
 <p:presentation xmlns:p="http://schemas.openxmlformats.org/presentationml/2006/main">
   <p:sldMasterIdLst>
-    <p:sldMasterId xmlns:r="http://schemas.openxmlformats.org/officeDocument/2006/relationships" id="2147483648" r:id="Rf7de838c4a2b47f9"/>
+    <p:sldMasterId xmlns:r="http://schemas.openxmlformats.org/officeDocument/2006/relationships" id="2147483648" r:id="Rafa6d82514f34271"/>
   </p:sldMasterIdLst>
   <p:notesMasterIdLst>
-    <p:notesMasterId xmlns:r="http://schemas.openxmlformats.org/officeDocument/2006/relationships" r:id="R47b2c721bb464f62"/>
+    <p:notesMasterId xmlns:r="http://schemas.openxmlformats.org/officeDocument/2006/relationships" r:id="Ra5d5931abe244221"/>
   </p:notesMasterIdLst>
   <p:sldIdLst>
-    <p:sldId xmlns:r="http://schemas.openxmlformats.org/officeDocument/2006/relationships" id="256" r:id="Rc3b9042a3af04d6c"/>
-    <p:sldId xmlns:r="http://schemas.openxmlformats.org/officeDocument/2006/relationships" id="257" r:id="Rae5e1c1bbbac4e8f"/>
-    <p:sldId xmlns:r="http://schemas.openxmlformats.org/officeDocument/2006/relationships" id="258" r:id="Rea9b15cad0ed402a"/>
-    <p:sldId xmlns:r="http://schemas.openxmlformats.org/officeDocument/2006/relationships" id="259" r:id="R4edfe0159bb74c93"/>
-    <p:sldId xmlns:r="http://schemas.openxmlformats.org/officeDocument/2006/relationships" id="260" r:id="R27a14924b4bb4693"/>
-    <p:sldId xmlns:r="http://schemas.openxmlformats.org/officeDocument/2006/relationships" id="261" r:id="Rd4c92383c4654f3b"/>
+    <p:sldId xmlns:r="http://schemas.openxmlformats.org/officeDocument/2006/relationships" id="256" r:id="R618b87ba53494615"/>
+    <p:sldId xmlns:r="http://schemas.openxmlformats.org/officeDocument/2006/relationships" id="257" r:id="R2c42421e108a4e46"/>
+    <p:sldId xmlns:r="http://schemas.openxmlformats.org/officeDocument/2006/relationships" id="258" r:id="R9bc968064cf84447"/>
+    <p:sldId xmlns:r="http://schemas.openxmlformats.org/officeDocument/2006/relationships" id="259" r:id="R605c8e0f66df44ad"/>
+    <p:sldId xmlns:r="http://schemas.openxmlformats.org/officeDocument/2006/relationships" id="260" r:id="Ra6b73a5df0a84fe5"/>
+    <p:sldId xmlns:r="http://schemas.openxmlformats.org/officeDocument/2006/relationships" id="261" r:id="R9f00c3dd83214e9d"/>
   </p:sldIdLst>
   <p:sldSz cx="12192000" cy="6858000"/>
   <p:notesSz cx="6858000" cy="9144000"/>
@@ -849,7 +849,7 @@
   </p:cSld>
   <p:clrMap bg1="lt1" tx1="dk1" bg2="lt2" tx2="dk2" accent1="accent1" accent2="accent2" accent3="accent3" accent4="accent4" accent5="accent5" accent6="accent6" hlink="hlink" folHlink="folHlink"/>
   <p:sldLayoutIdLst>
-    <p:sldLayoutId xmlns:r="http://schemas.openxmlformats.org/officeDocument/2006/relationships" id="2147483649" r:id="Rd29877f3460a412f"/>
+    <p:sldLayoutId xmlns:r="http://schemas.openxmlformats.org/officeDocument/2006/relationships" id="2147483649" r:id="R68367ae28bc44dcc"/>
   </p:sldLayoutIdLst>
   <p:txStyles>
     <p:titleStyle>
@@ -1429,6 +1429,7 @@
           <a:lstStyle xmlns:a="http://schemas.openxmlformats.org/drawingml/2006/main"/>
           <a:p xmlns:a="http://schemas.openxmlformats.org/drawingml/2006/main">
             <a:pPr algn="l">
+              <a:buNone/>
               <a:defRPr sz="1050" b="1">
                 <a:solidFill>
                   <a:srgbClr val="C7FF4A"/>
@@ -1486,6 +1487,7 @@
           <a:lstStyle xmlns:a="http://schemas.openxmlformats.org/drawingml/2006/main"/>
           <a:p xmlns:a="http://schemas.openxmlformats.org/drawingml/2006/main">
             <a:pPr algn="l">
+              <a:buNone/>
               <a:defRPr sz="4050" b="1">
                 <a:solidFill>
                   <a:srgbClr val="F4F1E8"/>
@@ -1509,6 +1511,7 @@
           </a:p>
           <a:p xmlns:a="http://schemas.openxmlformats.org/drawingml/2006/main">
             <a:pPr algn="l">
+              <a:buNone/>
               <a:defRPr sz="4050" b="1">
                 <a:solidFill>
                   <a:srgbClr val="F4F1E8"/>
@@ -1566,6 +1569,7 @@
           <a:lstStyle xmlns:a="http://schemas.openxmlformats.org/drawingml/2006/main"/>
           <a:p xmlns:a="http://schemas.openxmlformats.org/drawingml/2006/main">
             <a:pPr algn="l">
+              <a:buNone/>
               <a:defRPr sz="1800" b="0">
                 <a:solidFill>
                   <a:srgbClr val="9DA3AD"/>
@@ -1623,6 +1627,7 @@
           <a:lstStyle xmlns:a="http://schemas.openxmlformats.org/drawingml/2006/main"/>
           <a:p xmlns:a="http://schemas.openxmlformats.org/drawingml/2006/main">
             <a:pPr algn="l">
+              <a:buNone/>
               <a:defRPr sz="1200" b="1">
                 <a:solidFill>
                   <a:srgbClr val="F4F1E8"/>
@@ -1709,6 +1714,7 @@
           <a:lstStyle xmlns:a="http://schemas.openxmlformats.org/drawingml/2006/main"/>
           <a:p xmlns:a="http://schemas.openxmlformats.org/drawingml/2006/main">
             <a:pPr algn="l">
+              <a:buNone/>
               <a:defRPr sz="1050" b="1">
                 <a:solidFill>
                   <a:srgbClr val="C7FF4A"/>
@@ -1766,6 +1772,7 @@
           <a:lstStyle xmlns:a="http://schemas.openxmlformats.org/drawingml/2006/main"/>
           <a:p xmlns:a="http://schemas.openxmlformats.org/drawingml/2006/main">
             <a:pPr algn="l">
+              <a:buNone/>
               <a:defRPr sz="2550" b="1">
                 <a:solidFill>
                   <a:srgbClr val="F4F1E8"/>
@@ -1853,6 +1860,7 @@
           <a:lstStyle xmlns:a="http://schemas.openxmlformats.org/drawingml/2006/main"/>
           <a:p xmlns:a="http://schemas.openxmlformats.org/drawingml/2006/main">
             <a:pPr algn="r">
+              <a:buNone/>
               <a:defRPr sz="900" b="1">
                 <a:solidFill>
                   <a:srgbClr val="9DA3AD"/>
@@ -1910,6 +1918,7 @@
           <a:lstStyle xmlns:a="http://schemas.openxmlformats.org/drawingml/2006/main"/>
           <a:p xmlns:a="http://schemas.openxmlformats.org/drawingml/2006/main">
             <a:pPr algn="l">
+              <a:buNone/>
               <a:defRPr sz="1050" b="1">
                 <a:solidFill>
                   <a:srgbClr val="C7FF4A"/>
@@ -1967,6 +1976,7 @@
           <a:lstStyle xmlns:a="http://schemas.openxmlformats.org/drawingml/2006/main"/>
           <a:p xmlns:a="http://schemas.openxmlformats.org/drawingml/2006/main">
             <a:pPr algn="l">
+              <a:buNone/>
               <a:defRPr sz="2250" b="1">
                 <a:solidFill>
                   <a:srgbClr val="F4F1E8"/>
@@ -2024,6 +2034,7 @@
           <a:lstStyle xmlns:a="http://schemas.openxmlformats.org/drawingml/2006/main"/>
           <a:p xmlns:a="http://schemas.openxmlformats.org/drawingml/2006/main">
             <a:pPr algn="l">
+              <a:buNone/>
               <a:defRPr sz="1050" b="1">
                 <a:solidFill>
                   <a:srgbClr val="C7FF4A"/>
@@ -2081,6 +2092,7 @@
           <a:lstStyle xmlns:a="http://schemas.openxmlformats.org/drawingml/2006/main"/>
           <a:p xmlns:a="http://schemas.openxmlformats.org/drawingml/2006/main">
             <a:pPr algn="l">
+              <a:buNone/>
               <a:defRPr sz="1875" b="1">
                 <a:solidFill>
                   <a:srgbClr val="F4F1E8"/>
@@ -2104,6 +2116,7 @@
           </a:p>
           <a:p xmlns:a="http://schemas.openxmlformats.org/drawingml/2006/main">
             <a:pPr algn="l">
+              <a:buNone/>
               <a:defRPr sz="1875" b="1">
                 <a:solidFill>
                   <a:srgbClr val="F4F1E8"/>
@@ -2127,6 +2140,7 @@
           </a:p>
           <a:p xmlns:a="http://schemas.openxmlformats.org/drawingml/2006/main">
             <a:pPr algn="l">
+              <a:buNone/>
               <a:defRPr sz="1875" b="1">
                 <a:solidFill>
                   <a:srgbClr val="F4F1E8"/>
@@ -2184,6 +2198,7 @@
           <a:lstStyle xmlns:a="http://schemas.openxmlformats.org/drawingml/2006/main"/>
           <a:p xmlns:a="http://schemas.openxmlformats.org/drawingml/2006/main">
             <a:pPr algn="l">
+              <a:buNone/>
               <a:defRPr sz="2325" b="1">
                 <a:solidFill>
                   <a:srgbClr val="F4F1E8"/>
@@ -2241,6 +2256,7 @@
           <a:lstStyle xmlns:a="http://schemas.openxmlformats.org/drawingml/2006/main"/>
           <a:p xmlns:a="http://schemas.openxmlformats.org/drawingml/2006/main">
             <a:pPr algn="l">
+              <a:buNone/>
               <a:defRPr sz="1350" b="0">
                 <a:solidFill>
                   <a:srgbClr val="9DA3AD"/>
@@ -2327,6 +2343,7 @@
           <a:lstStyle xmlns:a="http://schemas.openxmlformats.org/drawingml/2006/main"/>
           <a:p xmlns:a="http://schemas.openxmlformats.org/drawingml/2006/main">
             <a:pPr algn="l">
+              <a:buNone/>
               <a:defRPr sz="1050" b="1">
                 <a:solidFill>
                   <a:srgbClr val="C7FF4A"/>
@@ -2384,6 +2401,7 @@
           <a:lstStyle xmlns:a="http://schemas.openxmlformats.org/drawingml/2006/main"/>
           <a:p xmlns:a="http://schemas.openxmlformats.org/drawingml/2006/main">
             <a:pPr algn="l">
+              <a:buNone/>
               <a:defRPr sz="2550" b="1">
                 <a:solidFill>
                   <a:srgbClr val="F4F1E8"/>
@@ -2471,6 +2489,7 @@
           <a:lstStyle xmlns:a="http://schemas.openxmlformats.org/drawingml/2006/main"/>
           <a:p xmlns:a="http://schemas.openxmlformats.org/drawingml/2006/main">
             <a:pPr algn="r">
+              <a:buNone/>
               <a:defRPr sz="900" b="1">
                 <a:solidFill>
                   <a:srgbClr val="9DA3AD"/>
@@ -2562,6 +2581,7 @@
           <a:lstStyle xmlns:a="http://schemas.openxmlformats.org/drawingml/2006/main"/>
           <a:p xmlns:a="http://schemas.openxmlformats.org/drawingml/2006/main">
             <a:pPr algn="l">
+              <a:buNone/>
               <a:defRPr sz="1050" b="1">
                 <a:solidFill>
                   <a:srgbClr val="FF6B6B"/>
@@ -2619,6 +2639,7 @@
           <a:lstStyle xmlns:a="http://schemas.openxmlformats.org/drawingml/2006/main"/>
           <a:p xmlns:a="http://schemas.openxmlformats.org/drawingml/2006/main">
             <a:pPr algn="l">
+              <a:buNone/>
               <a:defRPr sz="1800" b="1">
                 <a:solidFill>
                   <a:srgbClr val="F4F1E8"/>
@@ -2676,6 +2697,7 @@
           <a:lstStyle xmlns:a="http://schemas.openxmlformats.org/drawingml/2006/main"/>
           <a:p xmlns:a="http://schemas.openxmlformats.org/drawingml/2006/main">
             <a:pPr algn="l">
+              <a:buNone/>
               <a:defRPr sz="1575" b="0">
                 <a:solidFill>
                   <a:srgbClr val="9DA3AD"/>
@@ -2767,6 +2789,7 @@
           <a:lstStyle xmlns:a="http://schemas.openxmlformats.org/drawingml/2006/main"/>
           <a:p xmlns:a="http://schemas.openxmlformats.org/drawingml/2006/main">
             <a:pPr algn="l">
+              <a:buNone/>
               <a:defRPr sz="2550" b="1">
                 <a:solidFill>
                   <a:srgbClr val="FF6B6B"/>
@@ -2824,6 +2847,7 @@
           <a:lstStyle xmlns:a="http://schemas.openxmlformats.org/drawingml/2006/main"/>
           <a:p xmlns:a="http://schemas.openxmlformats.org/drawingml/2006/main">
             <a:pPr algn="l">
+              <a:buNone/>
               <a:defRPr sz="1725" b="1">
                 <a:solidFill>
                   <a:srgbClr val="F4F1E8"/>
@@ -2847,6 +2871,7 @@
           </a:p>
           <a:p xmlns:a="http://schemas.openxmlformats.org/drawingml/2006/main">
             <a:pPr algn="l">
+              <a:buNone/>
               <a:defRPr sz="1725" b="1">
                 <a:solidFill>
                   <a:srgbClr val="F4F1E8"/>
@@ -2904,6 +2929,7 @@
           <a:lstStyle xmlns:a="http://schemas.openxmlformats.org/drawingml/2006/main"/>
           <a:p xmlns:a="http://schemas.openxmlformats.org/drawingml/2006/main">
             <a:pPr algn="l">
+              <a:buNone/>
               <a:defRPr sz="1350" b="0">
                 <a:solidFill>
                   <a:srgbClr val="9DA3AD"/>
@@ -2927,6 +2953,7 @@
           </a:p>
           <a:p xmlns:a="http://schemas.openxmlformats.org/drawingml/2006/main">
             <a:pPr algn="l">
+              <a:buNone/>
               <a:defRPr sz="1350" b="0">
                 <a:solidFill>
                   <a:srgbClr val="9DA3AD"/>
@@ -2984,6 +3011,7 @@
           <a:lstStyle xmlns:a="http://schemas.openxmlformats.org/drawingml/2006/main"/>
           <a:p xmlns:a="http://schemas.openxmlformats.org/drawingml/2006/main">
             <a:pPr algn="l">
+              <a:buNone/>
               <a:defRPr sz="1800" b="1">
                 <a:solidFill>
                   <a:srgbClr val="F4F1E8"/>
@@ -3070,6 +3098,7 @@
           <a:lstStyle xmlns:a="http://schemas.openxmlformats.org/drawingml/2006/main"/>
           <a:p xmlns:a="http://schemas.openxmlformats.org/drawingml/2006/main">
             <a:pPr algn="l">
+              <a:buNone/>
               <a:defRPr sz="1050" b="1">
                 <a:solidFill>
                   <a:srgbClr val="C7FF4A"/>
@@ -3127,6 +3156,7 @@
           <a:lstStyle xmlns:a="http://schemas.openxmlformats.org/drawingml/2006/main"/>
           <a:p xmlns:a="http://schemas.openxmlformats.org/drawingml/2006/main">
             <a:pPr algn="l">
+              <a:buNone/>
               <a:defRPr sz="2550" b="1">
                 <a:solidFill>
                   <a:srgbClr val="F4F1E8"/>
@@ -3214,6 +3244,7 @@
           <a:lstStyle xmlns:a="http://schemas.openxmlformats.org/drawingml/2006/main"/>
           <a:p xmlns:a="http://schemas.openxmlformats.org/drawingml/2006/main">
             <a:pPr algn="r">
+              <a:buNone/>
               <a:defRPr sz="900" b="1">
                 <a:solidFill>
                   <a:srgbClr val="9DA3AD"/>
@@ -3305,6 +3336,7 @@
           <a:lstStyle xmlns:a="http://schemas.openxmlformats.org/drawingml/2006/main"/>
           <a:p xmlns:a="http://schemas.openxmlformats.org/drawingml/2006/main">
             <a:pPr algn="l">
+              <a:buNone/>
               <a:defRPr sz="1050" b="1">
                 <a:solidFill>
                   <a:srgbClr val="C7FF4A"/>
@@ -3362,6 +3394,7 @@
           <a:lstStyle xmlns:a="http://schemas.openxmlformats.org/drawingml/2006/main"/>
           <a:p xmlns:a="http://schemas.openxmlformats.org/drawingml/2006/main">
             <a:pPr algn="l">
+              <a:buNone/>
               <a:defRPr sz="1800" b="1">
                 <a:solidFill>
                   <a:srgbClr val="F4F1E8"/>
@@ -3419,6 +3452,7 @@
           <a:lstStyle xmlns:a="http://schemas.openxmlformats.org/drawingml/2006/main"/>
           <a:p xmlns:a="http://schemas.openxmlformats.org/drawingml/2006/main">
             <a:pPr algn="l">
+              <a:buNone/>
               <a:defRPr sz="1575" b="0">
                 <a:solidFill>
                   <a:srgbClr val="9DA3AD"/>
@@ -3510,6 +3544,7 @@
           <a:lstStyle xmlns:a="http://schemas.openxmlformats.org/drawingml/2006/main"/>
           <a:p xmlns:a="http://schemas.openxmlformats.org/drawingml/2006/main">
             <a:pPr algn="l">
+              <a:buNone/>
               <a:defRPr sz="2550" b="1">
                 <a:solidFill>
                   <a:srgbClr val="C7FF4A"/>
@@ -3567,6 +3602,7 @@
           <a:lstStyle xmlns:a="http://schemas.openxmlformats.org/drawingml/2006/main"/>
           <a:p xmlns:a="http://schemas.openxmlformats.org/drawingml/2006/main">
             <a:pPr algn="l">
+              <a:buNone/>
               <a:defRPr sz="1725" b="1">
                 <a:solidFill>
                   <a:srgbClr val="F4F1E8"/>
@@ -3590,6 +3626,7 @@
           </a:p>
           <a:p xmlns:a="http://schemas.openxmlformats.org/drawingml/2006/main">
             <a:pPr algn="l">
+              <a:buNone/>
               <a:defRPr sz="1725" b="1">
                 <a:solidFill>
                   <a:srgbClr val="F4F1E8"/>
@@ -3647,6 +3684,7 @@
           <a:lstStyle xmlns:a="http://schemas.openxmlformats.org/drawingml/2006/main"/>
           <a:p xmlns:a="http://schemas.openxmlformats.org/drawingml/2006/main">
             <a:pPr algn="l">
+              <a:buNone/>
               <a:defRPr sz="1350" b="0">
                 <a:solidFill>
                   <a:srgbClr val="9DA3AD"/>
@@ -3670,6 +3708,7 @@
           </a:p>
           <a:p xmlns:a="http://schemas.openxmlformats.org/drawingml/2006/main">
             <a:pPr algn="l">
+              <a:buNone/>
               <a:defRPr sz="1350" b="0">
                 <a:solidFill>
                   <a:srgbClr val="9DA3AD"/>
@@ -3727,6 +3766,7 @@
           <a:lstStyle xmlns:a="http://schemas.openxmlformats.org/drawingml/2006/main"/>
           <a:p xmlns:a="http://schemas.openxmlformats.org/drawingml/2006/main">
             <a:pPr algn="l">
+              <a:buNone/>
               <a:defRPr sz="1800" b="1">
                 <a:solidFill>
                   <a:srgbClr val="F4F1E8"/>
@@ -3813,6 +3853,7 @@
           <a:lstStyle xmlns:a="http://schemas.openxmlformats.org/drawingml/2006/main"/>
           <a:p xmlns:a="http://schemas.openxmlformats.org/drawingml/2006/main">
             <a:pPr algn="l">
+              <a:buNone/>
               <a:defRPr sz="1050" b="1">
                 <a:solidFill>
                   <a:srgbClr val="C7FF4A"/>
@@ -3870,6 +3911,7 @@
           <a:lstStyle xmlns:a="http://schemas.openxmlformats.org/drawingml/2006/main"/>
           <a:p xmlns:a="http://schemas.openxmlformats.org/drawingml/2006/main">
             <a:pPr algn="l">
+              <a:buNone/>
               <a:defRPr sz="2550" b="1">
                 <a:solidFill>
                   <a:srgbClr val="F4F1E8"/>
@@ -3957,6 +3999,7 @@
           <a:lstStyle xmlns:a="http://schemas.openxmlformats.org/drawingml/2006/main"/>
           <a:p xmlns:a="http://schemas.openxmlformats.org/drawingml/2006/main">
             <a:pPr algn="r">
+              <a:buNone/>
               <a:defRPr sz="900" b="1">
                 <a:solidFill>
                   <a:srgbClr val="9DA3AD"/>
@@ -4048,6 +4091,7 @@
           <a:lstStyle xmlns:a="http://schemas.openxmlformats.org/drawingml/2006/main"/>
           <a:p xmlns:a="http://schemas.openxmlformats.org/drawingml/2006/main">
             <a:pPr algn="ctr">
+              <a:buNone/>
               <a:defRPr sz="1575" b="1">
                 <a:solidFill>
                   <a:srgbClr val="F4F1E8"/>
@@ -4169,6 +4213,7 @@
           <a:lstStyle xmlns:a="http://schemas.openxmlformats.org/drawingml/2006/main"/>
           <a:p xmlns:a="http://schemas.openxmlformats.org/drawingml/2006/main">
             <a:pPr algn="ctr">
+              <a:buNone/>
               <a:defRPr sz="1575" b="1">
                 <a:solidFill>
                   <a:srgbClr val="F4F1E8"/>
@@ -4290,6 +4335,7 @@
           <a:lstStyle xmlns:a="http://schemas.openxmlformats.org/drawingml/2006/main"/>
           <a:p xmlns:a="http://schemas.openxmlformats.org/drawingml/2006/main">
             <a:pPr algn="ctr">
+              <a:buNone/>
               <a:defRPr sz="1575" b="1">
                 <a:solidFill>
                   <a:srgbClr val="F4F1E8"/>
@@ -4411,6 +4457,7 @@
           <a:lstStyle xmlns:a="http://schemas.openxmlformats.org/drawingml/2006/main"/>
           <a:p xmlns:a="http://schemas.openxmlformats.org/drawingml/2006/main">
             <a:pPr algn="ctr">
+              <a:buNone/>
               <a:defRPr sz="1575" b="1">
                 <a:solidFill>
                   <a:srgbClr val="F4F1E8"/>
@@ -4532,6 +4579,7 @@
           <a:lstStyle xmlns:a="http://schemas.openxmlformats.org/drawingml/2006/main"/>
           <a:p xmlns:a="http://schemas.openxmlformats.org/drawingml/2006/main">
             <a:pPr algn="ctr">
+              <a:buNone/>
               <a:defRPr sz="1575" b="1">
                 <a:solidFill>
                   <a:srgbClr val="C7FF4A"/>
@@ -4589,6 +4637,7 @@
           <a:lstStyle xmlns:a="http://schemas.openxmlformats.org/drawingml/2006/main"/>
           <a:p xmlns:a="http://schemas.openxmlformats.org/drawingml/2006/main">
             <a:pPr algn="l">
+              <a:buNone/>
               <a:defRPr sz="1650" b="1">
                 <a:solidFill>
                   <a:srgbClr val="F4F1E8"/>
@@ -4646,6 +4695,7 @@
           <a:lstStyle xmlns:a="http://schemas.openxmlformats.org/drawingml/2006/main"/>
           <a:p xmlns:a="http://schemas.openxmlformats.org/drawingml/2006/main">
             <a:pPr algn="l">
+              <a:buNone/>
               <a:defRPr sz="1650" b="1">
                 <a:solidFill>
                   <a:srgbClr val="F4F1E8"/>
@@ -4703,6 +4753,7 @@
           <a:lstStyle xmlns:a="http://schemas.openxmlformats.org/drawingml/2006/main"/>
           <a:p xmlns:a="http://schemas.openxmlformats.org/drawingml/2006/main">
             <a:pPr algn="l">
+              <a:buNone/>
               <a:defRPr sz="1425" b="0">
                 <a:solidFill>
                   <a:srgbClr val="9DA3AD"/>
@@ -4789,6 +4840,7 @@
           <a:lstStyle xmlns:a="http://schemas.openxmlformats.org/drawingml/2006/main"/>
           <a:p xmlns:a="http://schemas.openxmlformats.org/drawingml/2006/main">
             <a:pPr algn="l">
+              <a:buNone/>
               <a:defRPr sz="1050" b="1">
                 <a:solidFill>
                   <a:srgbClr val="C7FF4A"/>
@@ -4846,6 +4898,7 @@
           <a:lstStyle xmlns:a="http://schemas.openxmlformats.org/drawingml/2006/main"/>
           <a:p xmlns:a="http://schemas.openxmlformats.org/drawingml/2006/main">
             <a:pPr algn="l">
+              <a:buNone/>
               <a:defRPr sz="2550" b="1">
                 <a:solidFill>
                   <a:srgbClr val="F4F1E8"/>
@@ -4864,7 +4917,7 @@
                 <a:ea typeface="Bitstream Charter"/>
                 <a:cs typeface="Bitstream Charter"/>
               </a:rPr>
-              <a:t>Bob as the maintenance team</a:t>
+              <a:t>Workflow guidance for IBM Bob</a:t>
             </a:r>
           </a:p>
         </p:txBody>
@@ -4933,6 +4986,7 @@
           <a:lstStyle xmlns:a="http://schemas.openxmlformats.org/drawingml/2006/main"/>
           <a:p xmlns:a="http://schemas.openxmlformats.org/drawingml/2006/main">
             <a:pPr algn="r">
+              <a:buNone/>
               <a:defRPr sz="900" b="1">
                 <a:solidFill>
                   <a:srgbClr val="9DA3AD"/>
@@ -5024,6 +5078,7 @@
           <a:lstStyle xmlns:a="http://schemas.openxmlformats.org/drawingml/2006/main"/>
           <a:p xmlns:a="http://schemas.openxmlformats.org/drawingml/2006/main">
             <a:pPr algn="ctr">
+              <a:buNone/>
               <a:defRPr sz="1200" b="1">
                 <a:solidFill>
                   <a:srgbClr val="F4F1E8"/>
@@ -5145,6 +5200,7 @@
           <a:lstStyle xmlns:a="http://schemas.openxmlformats.org/drawingml/2006/main"/>
           <a:p xmlns:a="http://schemas.openxmlformats.org/drawingml/2006/main">
             <a:pPr algn="ctr">
+              <a:buNone/>
               <a:defRPr sz="1200" b="1">
                 <a:solidFill>
                   <a:srgbClr val="F4F1E8"/>
@@ -5266,6 +5322,7 @@
           <a:lstStyle xmlns:a="http://schemas.openxmlformats.org/drawingml/2006/main"/>
           <a:p xmlns:a="http://schemas.openxmlformats.org/drawingml/2006/main">
             <a:pPr algn="ctr">
+              <a:buNone/>
               <a:defRPr sz="1200" b="1">
                 <a:solidFill>
                   <a:srgbClr val="F4F1E8"/>
@@ -5387,6 +5444,7 @@
           <a:lstStyle xmlns:a="http://schemas.openxmlformats.org/drawingml/2006/main"/>
           <a:p xmlns:a="http://schemas.openxmlformats.org/drawingml/2006/main">
             <a:pPr algn="ctr">
+              <a:buNone/>
               <a:defRPr sz="1200" b="1">
                 <a:solidFill>
                   <a:srgbClr val="FF6B6B"/>
@@ -5508,6 +5566,7 @@
           <a:lstStyle xmlns:a="http://schemas.openxmlformats.org/drawingml/2006/main"/>
           <a:p xmlns:a="http://schemas.openxmlformats.org/drawingml/2006/main">
             <a:pPr algn="ctr">
+              <a:buNone/>
               <a:defRPr sz="1200" b="1">
                 <a:solidFill>
                   <a:srgbClr val="F4F1E8"/>
@@ -5560,11 +5619,12 @@
         </p:spPr>
         <p:txBody>
           <a:bodyPr xmlns:a="http://schemas.openxmlformats.org/drawingml/2006/main" anchor="ctr">
-            <a:normAutofit fontScale="89881"/>
+            <a:normAutofit fontScale="91516"/>
           </a:bodyPr>
           <a:lstStyle xmlns:a="http://schemas.openxmlformats.org/drawingml/2006/main"/>
           <a:p xmlns:a="http://schemas.openxmlformats.org/drawingml/2006/main">
             <a:pPr algn="l">
+              <a:buNone/>
               <a:defRPr sz="2100" b="1">
                 <a:solidFill>
                   <a:srgbClr val="F4F1E8"/>
@@ -5583,7 +5643,7 @@
                 <a:ea typeface="Bitstream Charter"/>
                 <a:cs typeface="Bitstream Charter"/>
               </a:rPr>
-              <a:t>Full-repository context connects the behavior map, tests, patch, criticism, and release evidence.</a:t>
+              <a:t>These Markdown roles describe a five-step handoff for a future IBM Bob IDE session.</a:t>
             </a:r>
           </a:p>
         </p:txBody>
@@ -5622,6 +5682,7 @@
           <a:lstStyle xmlns:a="http://schemas.openxmlformats.org/drawingml/2006/main"/>
           <a:p xmlns:a="http://schemas.openxmlformats.org/drawingml/2006/main">
             <a:pPr algn="l">
+              <a:buNone/>
               <a:defRPr sz="1500" b="0">
                 <a:solidFill>
                   <a:srgbClr val="9DA3AD"/>
@@ -5640,7 +5701,7 @@
                 <a:ea typeface="Bitstream Charter"/>
                 <a:cs typeface="Bitstream Charter"/>
               </a:rPr>
-              <a:t>The zero-key public demo is deterministic. Bob session exports remain separate, inspectable artifacts.</a:t>
+              <a:t>Current evidence comes from the deterministic zero-key demo. No Bob session export is included.</a:t>
             </a:r>
           </a:p>
         </p:txBody>
@@ -5679,6 +5740,7 @@
           <a:lstStyle xmlns:a="http://schemas.openxmlformats.org/drawingml/2006/main"/>
           <a:p xmlns:a="http://schemas.openxmlformats.org/drawingml/2006/main">
             <a:pPr algn="l">
+              <a:buNone/>
               <a:defRPr sz="2100" b="1">
                 <a:solidFill>
                   <a:srgbClr val="C7FF4A"/>

</xml_diff>